<commit_message>
docs(readme): crop evidence screenshot, specific alt texts, update PPT source pointers
</commit_message>
<xml_diff>
--- a/docs/复赛材料/finals-v1/MergePilot-复赛材料-v1.pptx
+++ b/docs/复赛材料/finals-v1/MergePilot-复赛材料-v1.pptx
@@ -791,7 +791,7 @@
           <a:p>
             <a:r>
               <a:rPr lang="en-US"/>
-              <a:t>- .impeccable/review/wide.png</a:t>
+              <a:t>- docs/assets/readme/preview4/console-overview-preview4.png</a:t>
             </a:r>
             <a:endParaRPr/>
           </a:p>
@@ -1212,12 +1212,12 @@
           </a:p>
           <a:p>
             <a:r>
-              <a:t>- .impeccable/review/desktop.png</a:t>
-            </a:r>
-          </a:p>
-          <a:p>
-            <a:r>
-              <a:t>- .impeccable/review/desktop-failed.png</a:t>
+              <a:t>- docs/assets/readme/preview4/console-overview-preview4.png</a:t>
+            </a:r>
+          </a:p>
+          <a:p>
+            <a:r>
+              <a:t>- docs/assets/readme/preview4/console-failed-preview4.png</a:t>
             </a:r>
           </a:p>
           <a:p>

</xml_diff>